<commit_message>
Rescope Ortho slides to Q2 vs Q1 and Q3 to date
Replaces the earlier two slides with exactly what was requested: one
slide comparing Q2 to Q1 and one on Q3 performance. The capacity
analysis, location breakdown and asks are removed.

Slide 2 covers Q2 vs Q1 — 1,449 against 1,256 new patients, up 15.4%,
90% of the Q2 plan against 84% in Q1, with a monthly actual-vs-plan
chart for January through June.

Slide 3 covers Q3 to date — July at 534 new patients, 102% of the July
plan and the highest attainment of the year, 24.3 per clinic day against
22.6 in Q2, with the August and September plan of 1,050 still ahead. The
chart compares monthly averages by quarter and labels Q3 as July only.

Co-Authored-By: Claude Opus 5 <noreply@anthropic.com>
Claude-Session: https://claude.ai/code/session_01MkMRAWDiiUj1quMHQAndcD
</commit_message>
<xml_diff>
--- a/analytics/Ortho-New-Patient-Growth-Joe-MacLean.pptx
+++ b/analytics/Ortho-New-Patient-Growth-Joe-MacLean.pptx
@@ -212,9 +212,9 @@
           </c:spPr>
           <c:cat>
             <c:strRef>
-              <c:f>Sheet1!$A$2:$A$8</c:f>
+              <c:f>Sheet1!$A$2:$A$7</c:f>
               <c:strCache>
-                <c:ptCount val="7"/>
+                <c:ptCount val="6"/>
                 <c:pt idx="0">
                   <c:v>Jan</c:v>
                 </c:pt>
@@ -233,18 +233,15 @@
                 <c:pt idx="5">
                   <c:v>Jun</c:v>
                 </c:pt>
-                <c:pt idx="6">
-                  <c:v>Jul</c:v>
-                </c:pt>
               </c:strCache>
             </c:strRef>
           </c:cat>
           <c:val>
             <c:numRef>
-              <c:f>Sheet1!$B$2:$B$8</c:f>
+              <c:f>Sheet1!$B$2:$B$7</c:f>
               <c:numCache>
                 <c:formatCode>General</c:formatCode>
-                <c:ptCount val="7"/>
+                <c:ptCount val="6"/>
                 <c:pt idx="0">
                   <c:v>450</c:v>
                 </c:pt>
@@ -262,9 +259,6 @@
                 </c:pt>
                 <c:pt idx="5">
                   <c:v>496</c:v>
-                </c:pt>
-                <c:pt idx="6">
-                  <c:v>534</c:v>
                 </c:pt>
               </c:numCache>
             </c:numRef>
@@ -291,9 +285,9 @@
           </c:spPr>
           <c:cat>
             <c:strRef>
-              <c:f>Sheet1!$A$2:$A$8</c:f>
+              <c:f>Sheet1!$A$2:$A$7</c:f>
               <c:strCache>
-                <c:ptCount val="7"/>
+                <c:ptCount val="6"/>
                 <c:pt idx="0">
                   <c:v>Jan</c:v>
                 </c:pt>
@@ -312,18 +306,15 @@
                 <c:pt idx="5">
                   <c:v>Jun</c:v>
                 </c:pt>
-                <c:pt idx="6">
-                  <c:v>Jul</c:v>
-                </c:pt>
               </c:strCache>
             </c:strRef>
           </c:cat>
           <c:val>
             <c:numRef>
-              <c:f>Sheet1!$C$2:$C$8</c:f>
+              <c:f>Sheet1!$C$2:$C$7</c:f>
               <c:numCache>
                 <c:formatCode>General</c:formatCode>
-                <c:ptCount val="7"/>
+                <c:ptCount val="6"/>
                 <c:pt idx="0">
                   <c:v>496</c:v>
                 </c:pt>
@@ -341,9 +332,6 @@
                 </c:pt>
                 <c:pt idx="5">
                   <c:v>560</c:v>
-                </c:pt>
-                <c:pt idx="6">
-                  <c:v>523</c:v>
                 </c:pt>
               </c:numCache>
             </c:numRef>
@@ -420,6 +408,271 @@
         <c:axId val="-2113994440"/>
         <c:scaling>
           <c:max val="700.0"/>
+          <c:min val="0.0"/>
+        </c:scaling>
+        <c:delete val="0"/>
+        <c:axPos val="l"/>
+        <c:majorGridlines>
+          <c:spPr>
+            <a:ln w="9525">
+              <a:solidFill>
+                <a:srgbClr val="E8EAEB"/>
+              </a:solidFill>
+            </a:ln>
+          </c:spPr>
+        </c:majorGridlines>
+        <c:majorTickMark val="out"/>
+        <c:minorTickMark val="none"/>
+        <c:tickLblPos val="nextTo"/>
+        <c:spPr>
+          <a:ln>
+            <a:noFill/>
+          </a:ln>
+        </c:spPr>
+        <c:txPr>
+          <a:bodyPr/>
+          <a:lstStyle/>
+          <a:p>
+            <a:pPr>
+              <a:defRPr sz="900">
+                <a:solidFill>
+                  <a:srgbClr val="6B7276"/>
+                </a:solidFill>
+                <a:latin typeface="Arial"/>
+              </a:defRPr>
+            </a:pPr>
+          </a:p>
+        </c:txPr>
+        <c:crossAx val="-2068027336"/>
+        <c:crosses val="autoZero"/>
+      </c:valAx>
+    </c:plotArea>
+    <c:legend>
+      <c:legendPos val="t"/>
+      <c:overlay val="0"/>
+      <c:txPr>
+        <a:bodyPr/>
+        <a:lstStyle/>
+        <a:p>
+          <a:pPr>
+            <a:defRPr sz="1000">
+              <a:solidFill>
+                <a:srgbClr val="363C40"/>
+              </a:solidFill>
+              <a:latin typeface="Arial"/>
+            </a:defRPr>
+          </a:pPr>
+        </a:p>
+      </c:txPr>
+    </c:legend>
+    <c:dispBlanksAs val="gap"/>
+  </c:chart>
+  <c:txPr>
+    <a:bodyPr/>
+    <a:lstStyle/>
+    <a:p>
+      <a:pPr>
+        <a:defRPr sz="1800"/>
+      </a:pPr>
+      <a:endParaRPr lang="en-US"/>
+    </a:p>
+  </c:txPr>
+  <c:externalData r:id="rId1">
+    <c:autoUpdate val="0"/>
+  </c:externalData>
+</c:chartSpace>
+</file>
+
+<file path=ppt/charts/chart2.xml><?xml version="1.0" encoding="utf-8"?>
+<c:chartSpace xmlns:c="http://schemas.openxmlformats.org/drawingml/2006/chart" xmlns:a="http://schemas.openxmlformats.org/drawingml/2006/main" xmlns:r="http://schemas.openxmlformats.org/officeDocument/2006/relationships">
+  <c:date1904 val="0"/>
+  <c:chart>
+    <c:autoTitleDeleted val="1"/>
+    <c:plotArea>
+      <c:barChart>
+        <c:barDir val="col"/>
+        <c:grouping val="clustered"/>
+        <c:ser>
+          <c:idx val="0"/>
+          <c:order val="0"/>
+          <c:tx>
+            <c:strRef>
+              <c:f>Sheet1!$B$1</c:f>
+              <c:strCache>
+                <c:ptCount val="1"/>
+                <c:pt idx="0">
+                  <c:v>Actual</c:v>
+                </c:pt>
+              </c:strCache>
+            </c:strRef>
+          </c:tx>
+          <c:spPr>
+            <a:solidFill>
+              <a:srgbClr val="49A698"/>
+            </a:solidFill>
+          </c:spPr>
+          <c:cat>
+            <c:strRef>
+              <c:f>Sheet1!$A$2:$A$4</c:f>
+              <c:strCache>
+                <c:ptCount val="3"/>
+                <c:pt idx="0">
+                  <c:v>Q1 (Jan–Mar)</c:v>
+                </c:pt>
+                <c:pt idx="1">
+                  <c:v>Q2 (Apr–Jun)</c:v>
+                </c:pt>
+                <c:pt idx="2">
+                  <c:v>Q3 (July only)</c:v>
+                </c:pt>
+              </c:strCache>
+            </c:strRef>
+          </c:cat>
+          <c:val>
+            <c:numRef>
+              <c:f>Sheet1!$B$2:$B$4</c:f>
+              <c:numCache>
+                <c:formatCode>General</c:formatCode>
+                <c:ptCount val="3"/>
+                <c:pt idx="0">
+                  <c:v>419</c:v>
+                </c:pt>
+                <c:pt idx="1">
+                  <c:v>483</c:v>
+                </c:pt>
+                <c:pt idx="2">
+                  <c:v>534</c:v>
+                </c:pt>
+              </c:numCache>
+            </c:numRef>
+          </c:val>
+        </c:ser>
+        <c:ser>
+          <c:idx val="1"/>
+          <c:order val="1"/>
+          <c:tx>
+            <c:strRef>
+              <c:f>Sheet1!$C$1</c:f>
+              <c:strCache>
+                <c:ptCount val="1"/>
+                <c:pt idx="0">
+                  <c:v>Plan</c:v>
+                </c:pt>
+              </c:strCache>
+            </c:strRef>
+          </c:tx>
+          <c:spPr>
+            <a:solidFill>
+              <a:srgbClr val="C1C6C8"/>
+            </a:solidFill>
+          </c:spPr>
+          <c:cat>
+            <c:strRef>
+              <c:f>Sheet1!$A$2:$A$4</c:f>
+              <c:strCache>
+                <c:ptCount val="3"/>
+                <c:pt idx="0">
+                  <c:v>Q1 (Jan–Mar)</c:v>
+                </c:pt>
+                <c:pt idx="1">
+                  <c:v>Q2 (Apr–Jun)</c:v>
+                </c:pt>
+                <c:pt idx="2">
+                  <c:v>Q3 (July only)</c:v>
+                </c:pt>
+              </c:strCache>
+            </c:strRef>
+          </c:cat>
+          <c:val>
+            <c:numRef>
+              <c:f>Sheet1!$C$2:$C$4</c:f>
+              <c:numCache>
+                <c:formatCode>General</c:formatCode>
+                <c:ptCount val="3"/>
+                <c:pt idx="0">
+                  <c:v>498</c:v>
+                </c:pt>
+                <c:pt idx="1">
+                  <c:v>536</c:v>
+                </c:pt>
+                <c:pt idx="2">
+                  <c:v>524</c:v>
+                </c:pt>
+              </c:numCache>
+            </c:numRef>
+          </c:val>
+        </c:ser>
+        <c:dLbls>
+          <c:txPr>
+            <a:bodyPr/>
+            <a:lstStyle/>
+            <a:p>
+              <a:pPr>
+                <a:defRPr sz="900" b="1">
+                  <a:solidFill>
+                    <a:srgbClr val="363C40"/>
+                  </a:solidFill>
+                  <a:latin typeface="Arial"/>
+                </a:defRPr>
+              </a:pPr>
+            </a:p>
+          </c:txPr>
+          <c:dLblPos val="outEnd"/>
+          <c:showLegendKey val="0"/>
+          <c:showVal val="1"/>
+          <c:showCatName val="0"/>
+          <c:showSerName val="0"/>
+          <c:showPercent val="0"/>
+          <c:showBubbleSize val="0"/>
+          <c:showLeaderLines val="1"/>
+        </c:dLbls>
+        <c:gapWidth val="60"/>
+        <c:overlap val="-10"/>
+        <c:axId val="-2068027336"/>
+        <c:axId val="-2113994440"/>
+      </c:barChart>
+      <c:catAx>
+        <c:axId val="-2068027336"/>
+        <c:scaling>
+          <c:orientation val="minMax"/>
+        </c:scaling>
+        <c:delete val="0"/>
+        <c:axPos val="b"/>
+        <c:majorTickMark val="out"/>
+        <c:minorTickMark val="none"/>
+        <c:tickLblPos val="nextTo"/>
+        <c:spPr>
+          <a:ln>
+            <a:solidFill>
+              <a:srgbClr val="C1C6C8"/>
+            </a:solidFill>
+          </a:ln>
+        </c:spPr>
+        <c:txPr>
+          <a:bodyPr/>
+          <a:lstStyle/>
+          <a:p>
+            <a:pPr>
+              <a:defRPr sz="1000">
+                <a:solidFill>
+                  <a:srgbClr val="363C40"/>
+                </a:solidFill>
+                <a:latin typeface="Arial"/>
+              </a:defRPr>
+            </a:pPr>
+          </a:p>
+        </c:txPr>
+        <c:crossAx val="-2113994440"/>
+        <c:crosses val="autoZero"/>
+        <c:auto val="1"/>
+        <c:lblAlgn val="ctr"/>
+        <c:lblOffset val="100"/>
+        <c:noMultiLvlLbl val="0"/>
+      </c:catAx>
+      <c:valAx>
+        <c:axId val="-2113994440"/>
+        <c:scaling>
+          <c:max val="640.0"/>
           <c:min val="0.0"/>
         </c:scaling>
         <c:delete val="0"/>
@@ -11879,7 +12132,7 @@
           <a:noFill/>
         </p:spPr>
         <p:txBody>
-          <a:bodyPr wrap="square" lIns="0" rIns="0" tIns="0" bIns="0" anchor="t">
+          <a:bodyPr wrap="square" lIns="0" rIns="0" tIns="0" bIns="0">
             <a:spAutoFit/>
           </a:bodyPr>
           <a:lstStyle/>
@@ -11892,7 +12145,7 @@
                 </a:solidFill>
                 <a:latin typeface="Arial"/>
               </a:rPr>
-              <a:t>Ortho new patients are growing — July was our best month of 2026</a:t>
+              <a:t>Q2 vs. Q1: Ortho new patients grew 15%</a:t>
             </a:r>
           </a:p>
         </p:txBody>
@@ -11914,7 +12167,7 @@
           <a:noFill/>
         </p:spPr>
         <p:txBody>
-          <a:bodyPr wrap="square" lIns="0" rIns="0" tIns="0" bIns="0" anchor="t">
+          <a:bodyPr wrap="square" lIns="0" rIns="0" tIns="0" bIns="0">
             <a:spAutoFit/>
           </a:bodyPr>
           <a:lstStyle/>
@@ -11927,7 +12180,7 @@
                 </a:solidFill>
                 <a:latin typeface="Arial"/>
               </a:rPr>
-              <a:t>We are still behind the plan set at the start of the year, and the gap is closing.</a:t>
+              <a:t>1,449 new patients in Q2 against 1,256 in Q1 — an increase of 193 patients.</a:t>
             </a:r>
           </a:p>
         </p:txBody>
@@ -11949,7 +12202,7 @@
             </a:avLst>
           </a:prstGeom>
           <a:solidFill>
-            <a:srgbClr val="EEF4F3"/>
+            <a:srgbClr val="F4F6F7"/>
           </a:solidFill>
           <a:ln>
             <a:noFill/>
@@ -11984,8 +12237,8 @@
         </p:nvSpPr>
         <p:spPr>
           <a:xfrm>
-            <a:off x="530352" y="1819656"/>
-            <a:ext cx="1682496" cy="566928"/>
+            <a:off x="530352" y="1828800"/>
+            <a:ext cx="1682496" cy="548640"/>
           </a:xfrm>
           <a:prstGeom prst="rect">
             <a:avLst/>
@@ -11993,7 +12246,7 @@
           <a:noFill/>
         </p:spPr>
         <p:txBody>
-          <a:bodyPr wrap="square" lIns="0" rIns="0" tIns="0" bIns="0" anchor="t">
+          <a:bodyPr wrap="square" lIns="0" rIns="0" tIns="0" bIns="0">
             <a:spAutoFit/>
           </a:bodyPr>
           <a:lstStyle/>
@@ -12002,11 +12255,11 @@
             <a:r>
               <a:rPr sz="3000" b="1">
                 <a:solidFill>
-                  <a:srgbClr val="49A698"/>
+                  <a:srgbClr val="363C40"/>
                 </a:solidFill>
                 <a:latin typeface="Arial"/>
               </a:rPr>
-              <a:t>534</a:t>
+              <a:t>1,256</a:t>
             </a:r>
           </a:p>
         </p:txBody>
@@ -12019,8 +12272,8 @@
         </p:nvSpPr>
         <p:spPr>
           <a:xfrm>
-            <a:off x="530352" y="2377440"/>
-            <a:ext cx="1682496" cy="310896"/>
+            <a:off x="530352" y="2395728"/>
+            <a:ext cx="1682496" cy="292607"/>
           </a:xfrm>
           <a:prstGeom prst="rect">
             <a:avLst/>
@@ -12028,7 +12281,7 @@
           <a:noFill/>
         </p:spPr>
         <p:txBody>
-          <a:bodyPr wrap="square" lIns="0" rIns="0" tIns="0" bIns="0" anchor="t">
+          <a:bodyPr wrap="square" lIns="0" rIns="0" tIns="0" bIns="0">
             <a:spAutoFit/>
           </a:bodyPr>
           <a:lstStyle/>
@@ -12041,7 +12294,7 @@
                 </a:solidFill>
                 <a:latin typeface="Arial"/>
               </a:rPr>
-              <a:t>New Ortho patients in July —</a:t>
+              <a:t>New Ortho patients in Q1</a:t>
             </a:r>
           </a:p>
           <a:p>
@@ -12053,7 +12306,7 @@
                 </a:solidFill>
                 <a:latin typeface="Arial"/>
               </a:rPr>
-              <a:t>the most in any month this year</a:t>
+              <a:t>(January–March)</a:t>
             </a:r>
           </a:p>
         </p:txBody>
@@ -12110,8 +12363,8 @@
         </p:nvSpPr>
         <p:spPr>
           <a:xfrm>
-            <a:off x="2679192" y="1819656"/>
-            <a:ext cx="1682496" cy="566928"/>
+            <a:off x="2679192" y="1828800"/>
+            <a:ext cx="1682496" cy="548640"/>
           </a:xfrm>
           <a:prstGeom prst="rect">
             <a:avLst/>
@@ -12119,7 +12372,7 @@
           <a:noFill/>
         </p:spPr>
         <p:txBody>
-          <a:bodyPr wrap="square" lIns="0" rIns="0" tIns="0" bIns="0" anchor="t">
+          <a:bodyPr wrap="square" lIns="0" rIns="0" tIns="0" bIns="0">
             <a:spAutoFit/>
           </a:bodyPr>
           <a:lstStyle/>
@@ -12132,7 +12385,7 @@
                 </a:solidFill>
                 <a:latin typeface="Arial"/>
               </a:rPr>
-              <a:t>+19%</a:t>
+              <a:t>1,449</a:t>
             </a:r>
           </a:p>
         </p:txBody>
@@ -12145,8 +12398,8 @@
         </p:nvSpPr>
         <p:spPr>
           <a:xfrm>
-            <a:off x="2679192" y="2377440"/>
-            <a:ext cx="1682496" cy="310896"/>
+            <a:off x="2679192" y="2395728"/>
+            <a:ext cx="1682496" cy="292607"/>
           </a:xfrm>
           <a:prstGeom prst="rect">
             <a:avLst/>
@@ -12154,7 +12407,7 @@
           <a:noFill/>
         </p:spPr>
         <p:txBody>
-          <a:bodyPr wrap="square" lIns="0" rIns="0" tIns="0" bIns="0" anchor="t">
+          <a:bodyPr wrap="square" lIns="0" rIns="0" tIns="0" bIns="0">
             <a:spAutoFit/>
           </a:bodyPr>
           <a:lstStyle/>
@@ -12167,7 +12420,7 @@
                 </a:solidFill>
                 <a:latin typeface="Arial"/>
               </a:rPr>
-              <a:t>More than January (450),</a:t>
+              <a:t>New Ortho patients in Q2</a:t>
             </a:r>
           </a:p>
           <a:p>
@@ -12179,7 +12432,7 @@
                 </a:solidFill>
                 <a:latin typeface="Arial"/>
               </a:rPr>
-              <a:t>after a slow first quarter</a:t>
+              <a:t>(April–June)</a:t>
             </a:r>
           </a:p>
         </p:txBody>
@@ -12236,8 +12489,8 @@
         </p:nvSpPr>
         <p:spPr>
           <a:xfrm>
-            <a:off x="4828032" y="1819656"/>
-            <a:ext cx="1682496" cy="566928"/>
+            <a:off x="4828032" y="1828800"/>
+            <a:ext cx="1682496" cy="548640"/>
           </a:xfrm>
           <a:prstGeom prst="rect">
             <a:avLst/>
@@ -12245,7 +12498,7 @@
           <a:noFill/>
         </p:spPr>
         <p:txBody>
-          <a:bodyPr wrap="square" lIns="0" rIns="0" tIns="0" bIns="0" anchor="t">
+          <a:bodyPr wrap="square" lIns="0" rIns="0" tIns="0" bIns="0">
             <a:spAutoFit/>
           </a:bodyPr>
           <a:lstStyle/>
@@ -12258,7 +12511,7 @@
                 </a:solidFill>
                 <a:latin typeface="Arial"/>
               </a:rPr>
-              <a:t>3,239</a:t>
+              <a:t>+15.4%</a:t>
             </a:r>
           </a:p>
         </p:txBody>
@@ -12271,8 +12524,8 @@
         </p:nvSpPr>
         <p:spPr>
           <a:xfrm>
-            <a:off x="4828032" y="2377440"/>
-            <a:ext cx="1682496" cy="310896"/>
+            <a:off x="4828032" y="2395728"/>
+            <a:ext cx="1682496" cy="292607"/>
           </a:xfrm>
           <a:prstGeom prst="rect">
             <a:avLst/>
@@ -12280,7 +12533,7 @@
           <a:noFill/>
         </p:spPr>
         <p:txBody>
-          <a:bodyPr wrap="square" lIns="0" rIns="0" tIns="0" bIns="0" anchor="t">
+          <a:bodyPr wrap="square" lIns="0" rIns="0" tIns="0" bIns="0">
             <a:spAutoFit/>
           </a:bodyPr>
           <a:lstStyle/>
@@ -12293,7 +12546,7 @@
                 </a:solidFill>
                 <a:latin typeface="Arial"/>
               </a:rPr>
-              <a:t>New Ortho patients so far</a:t>
+              <a:t>Q2 growth over Q1</a:t>
             </a:r>
           </a:p>
           <a:p>
@@ -12305,7 +12558,7 @@
                 </a:solidFill>
                 <a:latin typeface="Arial"/>
               </a:rPr>
-              <a:t>this year (January–July)</a:t>
+              <a:t>(+193 patients)</a:t>
             </a:r>
           </a:p>
         </p:txBody>
@@ -12362,8 +12615,8 @@
         </p:nvSpPr>
         <p:spPr>
           <a:xfrm>
-            <a:off x="6976872" y="1819656"/>
-            <a:ext cx="1682496" cy="566928"/>
+            <a:off x="6976872" y="1828800"/>
+            <a:ext cx="1682496" cy="548640"/>
           </a:xfrm>
           <a:prstGeom prst="rect">
             <a:avLst/>
@@ -12371,7 +12624,7 @@
           <a:noFill/>
         </p:spPr>
         <p:txBody>
-          <a:bodyPr wrap="square" lIns="0" rIns="0" tIns="0" bIns="0" anchor="t">
+          <a:bodyPr wrap="square" lIns="0" rIns="0" tIns="0" bIns="0">
             <a:spAutoFit/>
           </a:bodyPr>
           <a:lstStyle/>
@@ -12384,7 +12637,7 @@
                 </a:solidFill>
                 <a:latin typeface="Arial"/>
               </a:rPr>
-              <a:t>89%</a:t>
+              <a:t>90%</a:t>
             </a:r>
           </a:p>
         </p:txBody>
@@ -12397,8 +12650,8 @@
         </p:nvSpPr>
         <p:spPr>
           <a:xfrm>
-            <a:off x="6976872" y="2377440"/>
-            <a:ext cx="1682496" cy="310896"/>
+            <a:off x="6976872" y="2395728"/>
+            <a:ext cx="1682496" cy="292607"/>
           </a:xfrm>
           <a:prstGeom prst="rect">
             <a:avLst/>
@@ -12406,7 +12659,7 @@
           <a:noFill/>
         </p:spPr>
         <p:txBody>
-          <a:bodyPr wrap="square" lIns="0" rIns="0" tIns="0" bIns="0" anchor="t">
+          <a:bodyPr wrap="square" lIns="0" rIns="0" tIns="0" bIns="0">
             <a:spAutoFit/>
           </a:bodyPr>
           <a:lstStyle/>
@@ -12419,7 +12672,7 @@
                 </a:solidFill>
                 <a:latin typeface="Arial"/>
               </a:rPr>
-              <a:t>Of our January–July plan</a:t>
+              <a:t>Of the Q2 plan of 1,607,</a:t>
             </a:r>
           </a:p>
           <a:p>
@@ -12431,7 +12684,7 @@
                 </a:solidFill>
                 <a:latin typeface="Arial"/>
               </a:rPr>
-              <a:t>of 3,625 patients</a:t>
+              <a:t>up from 84% in Q1</a:t>
             </a:r>
           </a:p>
         </p:txBody>
@@ -12453,7 +12706,7 @@
           <a:noFill/>
         </p:spPr>
         <p:txBody>
-          <a:bodyPr wrap="square" lIns="0" rIns="0" tIns="0" bIns="0" anchor="t">
+          <a:bodyPr wrap="square" lIns="0" rIns="0" tIns="0" bIns="0">
             <a:spAutoFit/>
           </a:bodyPr>
           <a:lstStyle/>
@@ -12466,7 +12719,7 @@
                 </a:solidFill>
                 <a:latin typeface="Arial"/>
               </a:rPr>
-              <a:t>New Ortho patients each month, actual vs. plan</a:t>
+              <a:t>New Ortho patients by month, actual vs. plan</a:t>
             </a:r>
           </a:p>
         </p:txBody>
@@ -12506,21 +12759,12 @@
           <a:noFill/>
         </p:spPr>
         <p:txBody>
-          <a:bodyPr wrap="square" lIns="0" rIns="0" tIns="0" bIns="0" anchor="t">
+          <a:bodyPr wrap="square" lIns="0" rIns="0" tIns="0" bIns="0">
             <a:spAutoFit/>
           </a:bodyPr>
           <a:lstStyle/>
           <a:p>
             <a:pPr algn="l"/>
-            <a:r>
-              <a:rPr sz="1050" b="1">
-                <a:solidFill>
-                  <a:srgbClr val="49A698"/>
-                </a:solidFill>
-                <a:latin typeface="Arial"/>
-              </a:rPr>
-              <a:t>What this says:  </a:t>
-            </a:r>
             <a:r>
               <a:rPr sz="1050" b="0">
                 <a:solidFill>
@@ -12528,7 +12772,7 @@
                 </a:solidFill>
                 <a:latin typeface="Arial"/>
               </a:rPr>
-              <a:t>The slow start was January through March. Since April we have added patients every month, and the monthly shortfall against plan has roughly halved. The trend is right; we have not yet made up the early gap.</a:t>
+              <a:t>Every month in Q2 was above every month in Q1. Adjusted for the number of clinic days, Q2 ran 22.6 new patients per day against 19.9 in Q1, an increase of 13.6%. May finished above plan; March was the weakest month of the year at 74% of plan.</a:t>
             </a:r>
           </a:p>
         </p:txBody>
@@ -12550,7 +12794,7 @@
           <a:noFill/>
         </p:spPr>
         <p:txBody>
-          <a:bodyPr wrap="square" lIns="0" rIns="0" tIns="0" bIns="0" anchor="t">
+          <a:bodyPr wrap="square" lIns="0" rIns="0" tIns="0" bIns="0">
             <a:spAutoFit/>
           </a:bodyPr>
           <a:lstStyle/>
@@ -12827,7 +13071,7 @@
           <a:noFill/>
         </p:spPr>
         <p:txBody>
-          <a:bodyPr wrap="square" lIns="0" rIns="0" tIns="0" bIns="0" anchor="t">
+          <a:bodyPr wrap="square" lIns="0" rIns="0" tIns="0" bIns="0">
             <a:spAutoFit/>
           </a:bodyPr>
           <a:lstStyle/>
@@ -12840,7 +13084,7 @@
                 </a:solidFill>
                 <a:latin typeface="Arial"/>
               </a:rPr>
-              <a:t>The gap is not patient demand — it is unfilled clinic time</a:t>
+              <a:t>Q3 to date: July was the strongest month of 2026</a:t>
             </a:r>
           </a:p>
         </p:txBody>
@@ -12862,7 +13106,7 @@
           <a:noFill/>
         </p:spPr>
         <p:txBody>
-          <a:bodyPr wrap="square" lIns="0" rIns="0" tIns="0" bIns="0" anchor="t">
+          <a:bodyPr wrap="square" lIns="0" rIns="0" tIns="0" bIns="0">
             <a:spAutoFit/>
           </a:bodyPr>
           <a:lstStyle/>
@@ -12875,7 +13119,7 @@
                 </a:solidFill>
                 <a:latin typeface="Arial"/>
               </a:rPr>
-              <a:t>Between 30 March and 30 July, Ortho clinics ran about four-fifths full.</a:t>
+              <a:t>Q3 is one month in. August and September remain.</a:t>
             </a:r>
           </a:p>
         </p:txBody>
@@ -12889,7 +13133,7 @@
         <p:spPr>
           <a:xfrm>
             <a:off x="384048" y="1700784"/>
-            <a:ext cx="2688336" cy="1060704"/>
+            <a:ext cx="1975104" cy="1097280"/>
           </a:xfrm>
           <a:prstGeom prst="roundRect">
             <a:avLst>
@@ -12932,8 +13176,8 @@
         </p:nvSpPr>
         <p:spPr>
           <a:xfrm>
-            <a:off x="530352" y="1819656"/>
-            <a:ext cx="2395728" cy="566928"/>
+            <a:off x="530352" y="1828800"/>
+            <a:ext cx="1682496" cy="548640"/>
           </a:xfrm>
           <a:prstGeom prst="rect">
             <a:avLst/>
@@ -12941,7 +13185,7 @@
           <a:noFill/>
         </p:spPr>
         <p:txBody>
-          <a:bodyPr wrap="square" lIns="0" rIns="0" tIns="0" bIns="0" anchor="t">
+          <a:bodyPr wrap="square" lIns="0" rIns="0" tIns="0" bIns="0">
             <a:spAutoFit/>
           </a:bodyPr>
           <a:lstStyle/>
@@ -12954,7 +13198,7 @@
                 </a:solidFill>
                 <a:latin typeface="Arial"/>
               </a:rPr>
-              <a:t>79%</a:t>
+              <a:t>534</a:t>
             </a:r>
           </a:p>
         </p:txBody>
@@ -12967,8 +13211,8 @@
         </p:nvSpPr>
         <p:spPr>
           <a:xfrm>
-            <a:off x="530352" y="2377440"/>
-            <a:ext cx="2395728" cy="274319"/>
+            <a:off x="530352" y="2395728"/>
+            <a:ext cx="1682496" cy="292607"/>
           </a:xfrm>
           <a:prstGeom prst="rect">
             <a:avLst/>
@@ -12976,7 +13220,7 @@
           <a:noFill/>
         </p:spPr>
         <p:txBody>
-          <a:bodyPr wrap="square" lIns="0" rIns="0" tIns="0" bIns="0" anchor="t">
+          <a:bodyPr wrap="square" lIns="0" rIns="0" tIns="0" bIns="0">
             <a:spAutoFit/>
           </a:bodyPr>
           <a:lstStyle/>
@@ -12989,7 +13233,7 @@
                 </a:solidFill>
                 <a:latin typeface="Arial"/>
               </a:rPr>
-              <a:t>Of available Ortho appointment</a:t>
+              <a:t>New Ortho patients in July —</a:t>
             </a:r>
           </a:p>
           <a:p>
@@ -13001,7 +13245,7 @@
                 </a:solidFill>
                 <a:latin typeface="Arial"/>
               </a:rPr>
-              <a:t>times were booked</a:t>
+              <a:t>the most in any month this year</a:t>
             </a:r>
           </a:p>
         </p:txBody>
@@ -13014,8 +13258,8 @@
         </p:nvSpPr>
         <p:spPr>
           <a:xfrm>
-            <a:off x="3255264" y="1700784"/>
-            <a:ext cx="2688336" cy="1060704"/>
+            <a:off x="2532888" y="1700784"/>
+            <a:ext cx="1975104" cy="1097280"/>
           </a:xfrm>
           <a:prstGeom prst="roundRect">
             <a:avLst>
@@ -13058,8 +13302,8 @@
         </p:nvSpPr>
         <p:spPr>
           <a:xfrm>
-            <a:off x="3401568" y="1819656"/>
-            <a:ext cx="2395728" cy="566928"/>
+            <a:off x="2679192" y="1828800"/>
+            <a:ext cx="1682496" cy="548640"/>
           </a:xfrm>
           <a:prstGeom prst="rect">
             <a:avLst/>
@@ -13067,7 +13311,7 @@
           <a:noFill/>
         </p:spPr>
         <p:txBody>
-          <a:bodyPr wrap="square" lIns="0" rIns="0" tIns="0" bIns="0" anchor="t">
+          <a:bodyPr wrap="square" lIns="0" rIns="0" tIns="0" bIns="0">
             <a:spAutoFit/>
           </a:bodyPr>
           <a:lstStyle/>
@@ -13080,7 +13324,7 @@
                 </a:solidFill>
                 <a:latin typeface="Arial"/>
               </a:rPr>
-              <a:t>3,233</a:t>
+              <a:t>102%</a:t>
             </a:r>
           </a:p>
         </p:txBody>
@@ -13093,8 +13337,8 @@
         </p:nvSpPr>
         <p:spPr>
           <a:xfrm>
-            <a:off x="3401568" y="2377440"/>
-            <a:ext cx="2395728" cy="274319"/>
+            <a:off x="2679192" y="2395728"/>
+            <a:ext cx="1682496" cy="292607"/>
           </a:xfrm>
           <a:prstGeom prst="rect">
             <a:avLst/>
@@ -13102,7 +13346,7 @@
           <a:noFill/>
         </p:spPr>
         <p:txBody>
-          <a:bodyPr wrap="square" lIns="0" rIns="0" tIns="0" bIns="0" anchor="t">
+          <a:bodyPr wrap="square" lIns="0" rIns="0" tIns="0" bIns="0">
             <a:spAutoFit/>
           </a:bodyPr>
           <a:lstStyle/>
@@ -13115,7 +13359,7 @@
                 </a:solidFill>
                 <a:latin typeface="Arial"/>
               </a:rPr>
-              <a:t>Ortho appointment times went</a:t>
+              <a:t>Of the July plan of 523 —</a:t>
             </a:r>
           </a:p>
           <a:p>
@@ -13127,7 +13371,7 @@
                 </a:solidFill>
                 <a:latin typeface="Arial"/>
               </a:rPr>
-              <a:t>unused over those four months</a:t>
+              <a:t>the best attainment this year</a:t>
             </a:r>
           </a:p>
         </p:txBody>
@@ -13140,8 +13384,8 @@
         </p:nvSpPr>
         <p:spPr>
           <a:xfrm>
-            <a:off x="6126480" y="1700784"/>
-            <a:ext cx="2688336" cy="1060704"/>
+            <a:off x="4681728" y="1700784"/>
+            <a:ext cx="1975104" cy="1097280"/>
           </a:xfrm>
           <a:prstGeom prst="roundRect">
             <a:avLst>
@@ -13149,7 +13393,7 @@
             </a:avLst>
           </a:prstGeom>
           <a:solidFill>
-            <a:srgbClr val="E8F3F1"/>
+            <a:srgbClr val="EEF4F3"/>
           </a:solidFill>
           <a:ln>
             <a:noFill/>
@@ -13184,8 +13428,8 @@
         </p:nvSpPr>
         <p:spPr>
           <a:xfrm>
-            <a:off x="6272784" y="1819656"/>
-            <a:ext cx="2395728" cy="566928"/>
+            <a:off x="4828032" y="1828800"/>
+            <a:ext cx="1682496" cy="548640"/>
           </a:xfrm>
           <a:prstGeom prst="rect">
             <a:avLst/>
@@ -13193,7 +13437,7 @@
           <a:noFill/>
         </p:spPr>
         <p:txBody>
-          <a:bodyPr wrap="square" lIns="0" rIns="0" tIns="0" bIns="0" anchor="t">
+          <a:bodyPr wrap="square" lIns="0" rIns="0" tIns="0" bIns="0">
             <a:spAutoFit/>
           </a:bodyPr>
           <a:lstStyle/>
@@ -13206,7 +13450,7 @@
                 </a:solidFill>
                 <a:latin typeface="Arial"/>
               </a:rPr>
-              <a:t>+626</a:t>
+              <a:t>24.3</a:t>
             </a:r>
           </a:p>
         </p:txBody>
@@ -13219,8 +13463,8 @@
         </p:nvSpPr>
         <p:spPr>
           <a:xfrm>
-            <a:off x="6272784" y="2377440"/>
-            <a:ext cx="2395728" cy="274319"/>
+            <a:off x="4828032" y="2395728"/>
+            <a:ext cx="1682496" cy="292607"/>
           </a:xfrm>
           <a:prstGeom prst="rect">
             <a:avLst/>
@@ -13228,7 +13472,7 @@
           <a:noFill/>
         </p:spPr>
         <p:txBody>
-          <a:bodyPr wrap="square" lIns="0" rIns="0" tIns="0" bIns="0" anchor="t">
+          <a:bodyPr wrap="square" lIns="0" rIns="0" tIns="0" bIns="0">
             <a:spAutoFit/>
           </a:bodyPr>
           <a:lstStyle/>
@@ -13241,7 +13485,7 @@
                 </a:solidFill>
                 <a:latin typeface="Arial"/>
               </a:rPr>
-              <a:t>More new patients a year if we</a:t>
+              <a:t>New patients per clinic day,</a:t>
             </a:r>
           </a:p>
           <a:p>
@@ -13253,161 +13497,21 @@
                 </a:solidFill>
                 <a:latin typeface="Arial"/>
               </a:rPr>
-              <a:t>filled those clinics to 90%</a:t>
-            </a:r>
-          </a:p>
-        </p:txBody>
-      </p:sp>
-      <p:sp>
-        <p:nvSpPr>
-          <p:cNvPr id="27" name="TextBox 26"/>
-          <p:cNvSpPr txBox="1"/>
-          <p:nvPr/>
-        </p:nvSpPr>
-        <p:spPr>
-          <a:xfrm>
-            <a:off x="384048" y="2944368"/>
-            <a:ext cx="4023360" cy="237744"/>
-          </a:xfrm>
-          <a:prstGeom prst="rect">
-            <a:avLst/>
-          </a:prstGeom>
-          <a:noFill/>
-        </p:spPr>
-        <p:txBody>
-          <a:bodyPr wrap="square" lIns="0" rIns="0" tIns="0" bIns="0" anchor="t">
-            <a:spAutoFit/>
-          </a:bodyPr>
-          <a:lstStyle/>
-          <a:p>
-            <a:pPr algn="l"/>
-            <a:r>
-              <a:rPr sz="1100" b="1">
-                <a:solidFill>
-                  <a:srgbClr val="363C40"/>
-                </a:solidFill>
-                <a:latin typeface="Arial"/>
-              </a:rPr>
-              <a:t>Where the open time is</a:t>
-            </a:r>
-          </a:p>
-        </p:txBody>
-      </p:sp>
-      <p:sp>
-        <p:nvSpPr>
-          <p:cNvPr id="28" name="TextBox 27"/>
-          <p:cNvSpPr txBox="1"/>
-          <p:nvPr/>
-        </p:nvSpPr>
-        <p:spPr>
-          <a:xfrm>
-            <a:off x="384048" y="3255264"/>
-            <a:ext cx="1874519" cy="182880"/>
-          </a:xfrm>
-          <a:prstGeom prst="rect">
-            <a:avLst/>
-          </a:prstGeom>
-          <a:noFill/>
-        </p:spPr>
-        <p:txBody>
-          <a:bodyPr wrap="square" lIns="0" rIns="0" tIns="0" bIns="0" anchor="t">
-            <a:spAutoFit/>
-          </a:bodyPr>
-          <a:lstStyle/>
-          <a:p>
-            <a:pPr algn="l"/>
-            <a:r>
-              <a:rPr sz="850" b="1">
-                <a:solidFill>
-                  <a:srgbClr val="6B7276"/>
-                </a:solidFill>
-                <a:latin typeface="Arial"/>
-              </a:rPr>
-              <a:t>Location</a:t>
-            </a:r>
-          </a:p>
-        </p:txBody>
-      </p:sp>
-      <p:sp>
-        <p:nvSpPr>
-          <p:cNvPr id="29" name="TextBox 28"/>
-          <p:cNvSpPr txBox="1"/>
-          <p:nvPr/>
-        </p:nvSpPr>
-        <p:spPr>
-          <a:xfrm>
-            <a:off x="2331720" y="3255264"/>
-            <a:ext cx="731520" cy="182880"/>
-          </a:xfrm>
-          <a:prstGeom prst="rect">
-            <a:avLst/>
-          </a:prstGeom>
-          <a:noFill/>
-        </p:spPr>
-        <p:txBody>
-          <a:bodyPr wrap="square" lIns="0" rIns="0" tIns="0" bIns="0" anchor="t">
-            <a:spAutoFit/>
-          </a:bodyPr>
-          <a:lstStyle/>
-          <a:p>
-            <a:pPr algn="r"/>
-            <a:r>
-              <a:rPr sz="850" b="1">
-                <a:solidFill>
-                  <a:srgbClr val="6B7276"/>
-                </a:solidFill>
-                <a:latin typeface="Arial"/>
-              </a:rPr>
-              <a:t>% full</a:t>
-            </a:r>
-          </a:p>
-        </p:txBody>
-      </p:sp>
-      <p:sp>
-        <p:nvSpPr>
-          <p:cNvPr id="30" name="TextBox 29"/>
-          <p:cNvSpPr txBox="1"/>
-          <p:nvPr/>
-        </p:nvSpPr>
-        <p:spPr>
-          <a:xfrm>
-            <a:off x="3154680" y="3255264"/>
-            <a:ext cx="1234440" cy="182880"/>
-          </a:xfrm>
-          <a:prstGeom prst="rect">
-            <a:avLst/>
-          </a:prstGeom>
-          <a:noFill/>
-        </p:spPr>
-        <p:txBody>
-          <a:bodyPr wrap="square" lIns="0" rIns="0" tIns="0" bIns="0" anchor="t">
-            <a:spAutoFit/>
-          </a:bodyPr>
-          <a:lstStyle/>
-          <a:p>
-            <a:pPr algn="r"/>
-            <a:r>
-              <a:rPr sz="850" b="1">
-                <a:solidFill>
-                  <a:srgbClr val="6B7276"/>
-                </a:solidFill>
-                <a:latin typeface="Arial"/>
-              </a:rPr>
-              <a:t>Open times</a:t>
-            </a:r>
-          </a:p>
-        </p:txBody>
-      </p:sp>
-      <p:sp>
-        <p:nvSpPr>
-          <p:cNvPr id="31" name="Rounded Rectangle 30"/>
+              <a:t>up from 22.6 in Q2</a:t>
+            </a:r>
+          </a:p>
+        </p:txBody>
+      </p:sp>
+      <p:sp>
+        <p:nvSpPr>
+          <p:cNvPr id="27" name="Rounded Rectangle 26"/>
           <p:cNvSpPr/>
           <p:nvPr/>
         </p:nvSpPr>
         <p:spPr>
           <a:xfrm>
-            <a:off x="329184" y="3433572"/>
-            <a:ext cx="4114800" cy="310896"/>
+            <a:off x="6830568" y="1700784"/>
+            <a:ext cx="1975104" cy="1097280"/>
           </a:xfrm>
           <a:prstGeom prst="roundRect">
             <a:avLst>
@@ -13415,7 +13519,7 @@
             </a:avLst>
           </a:prstGeom>
           <a:solidFill>
-            <a:srgbClr val="F6F8F9"/>
+            <a:srgbClr val="F4F6F7"/>
           </a:solidFill>
           <a:ln>
             <a:noFill/>
@@ -13444,14 +13548,14 @@
       </p:sp>
       <p:sp>
         <p:nvSpPr>
-          <p:cNvPr id="32" name="TextBox 31"/>
+          <p:cNvPr id="28" name="TextBox 27"/>
           <p:cNvSpPr txBox="1"/>
           <p:nvPr/>
         </p:nvSpPr>
         <p:spPr>
           <a:xfrm>
-            <a:off x="384048" y="3474720"/>
-            <a:ext cx="1874519" cy="237744"/>
+            <a:off x="6976872" y="1828800"/>
+            <a:ext cx="1682496" cy="548640"/>
           </a:xfrm>
           <a:prstGeom prst="rect">
             <a:avLst/>
@@ -13459,34 +13563,34 @@
           <a:noFill/>
         </p:spPr>
         <p:txBody>
-          <a:bodyPr wrap="square" lIns="0" rIns="0" tIns="0" bIns="0" anchor="t">
+          <a:bodyPr wrap="square" lIns="0" rIns="0" tIns="0" bIns="0">
             <a:spAutoFit/>
           </a:bodyPr>
           <a:lstStyle/>
           <a:p>
             <a:pPr algn="l"/>
             <a:r>
-              <a:rPr sz="1000" b="0">
+              <a:rPr sz="3000" b="1">
                 <a:solidFill>
                   <a:srgbClr val="363C40"/>
                 </a:solidFill>
                 <a:latin typeface="Arial"/>
               </a:rPr>
-              <a:t>Sterling Heights</a:t>
-            </a:r>
-          </a:p>
-        </p:txBody>
-      </p:sp>
-      <p:sp>
-        <p:nvSpPr>
-          <p:cNvPr id="33" name="TextBox 32"/>
+              <a:t>1,050</a:t>
+            </a:r>
+          </a:p>
+        </p:txBody>
+      </p:sp>
+      <p:sp>
+        <p:nvSpPr>
+          <p:cNvPr id="29" name="TextBox 28"/>
           <p:cNvSpPr txBox="1"/>
           <p:nvPr/>
         </p:nvSpPr>
         <p:spPr>
           <a:xfrm>
-            <a:off x="2331720" y="3474720"/>
-            <a:ext cx="731520" cy="237744"/>
+            <a:off x="6976872" y="2395728"/>
+            <a:ext cx="1682496" cy="292607"/>
           </a:xfrm>
           <a:prstGeom prst="rect">
             <a:avLst/>
@@ -13494,644 +13598,10 @@
           <a:noFill/>
         </p:spPr>
         <p:txBody>
-          <a:bodyPr wrap="square" lIns="0" rIns="0" tIns="0" bIns="0" anchor="t">
+          <a:bodyPr wrap="square" lIns="0" rIns="0" tIns="0" bIns="0">
             <a:spAutoFit/>
           </a:bodyPr>
           <a:lstStyle/>
-          <a:p>
-            <a:pPr algn="r"/>
-            <a:r>
-              <a:rPr sz="1000" b="1">
-                <a:solidFill>
-                  <a:srgbClr val="CE4A57"/>
-                </a:solidFill>
-                <a:latin typeface="Arial"/>
-              </a:rPr>
-              <a:t>75%</a:t>
-            </a:r>
-          </a:p>
-        </p:txBody>
-      </p:sp>
-      <p:sp>
-        <p:nvSpPr>
-          <p:cNvPr id="34" name="TextBox 33"/>
-          <p:cNvSpPr txBox="1"/>
-          <p:nvPr/>
-        </p:nvSpPr>
-        <p:spPr>
-          <a:xfrm>
-            <a:off x="3154680" y="3474720"/>
-            <a:ext cx="1234440" cy="237744"/>
-          </a:xfrm>
-          <a:prstGeom prst="rect">
-            <a:avLst/>
-          </a:prstGeom>
-          <a:noFill/>
-        </p:spPr>
-        <p:txBody>
-          <a:bodyPr wrap="square" lIns="0" rIns="0" tIns="0" bIns="0" anchor="t">
-            <a:spAutoFit/>
-          </a:bodyPr>
-          <a:lstStyle/>
-          <a:p>
-            <a:pPr algn="r"/>
-            <a:r>
-              <a:rPr sz="1000" b="1">
-                <a:solidFill>
-                  <a:srgbClr val="363C40"/>
-                </a:solidFill>
-                <a:latin typeface="Arial"/>
-              </a:rPr>
-              <a:t>1,621</a:t>
-            </a:r>
-          </a:p>
-        </p:txBody>
-      </p:sp>
-      <p:sp>
-        <p:nvSpPr>
-          <p:cNvPr id="35" name="TextBox 34"/>
-          <p:cNvSpPr txBox="1"/>
-          <p:nvPr/>
-        </p:nvSpPr>
-        <p:spPr>
-          <a:xfrm>
-            <a:off x="384048" y="3822191"/>
-            <a:ext cx="1874519" cy="237744"/>
-          </a:xfrm>
-          <a:prstGeom prst="rect">
-            <a:avLst/>
-          </a:prstGeom>
-          <a:noFill/>
-        </p:spPr>
-        <p:txBody>
-          <a:bodyPr wrap="square" lIns="0" rIns="0" tIns="0" bIns="0" anchor="t">
-            <a:spAutoFit/>
-          </a:bodyPr>
-          <a:lstStyle/>
-          <a:p>
-            <a:pPr algn="l"/>
-            <a:r>
-              <a:rPr sz="1000" b="0">
-                <a:solidFill>
-                  <a:srgbClr val="363C40"/>
-                </a:solidFill>
-                <a:latin typeface="Arial"/>
-              </a:rPr>
-              <a:t>Livonia</a:t>
-            </a:r>
-          </a:p>
-        </p:txBody>
-      </p:sp>
-      <p:sp>
-        <p:nvSpPr>
-          <p:cNvPr id="36" name="TextBox 35"/>
-          <p:cNvSpPr txBox="1"/>
-          <p:nvPr/>
-        </p:nvSpPr>
-        <p:spPr>
-          <a:xfrm>
-            <a:off x="2331720" y="3822191"/>
-            <a:ext cx="731520" cy="237744"/>
-          </a:xfrm>
-          <a:prstGeom prst="rect">
-            <a:avLst/>
-          </a:prstGeom>
-          <a:noFill/>
-        </p:spPr>
-        <p:txBody>
-          <a:bodyPr wrap="square" lIns="0" rIns="0" tIns="0" bIns="0" anchor="t">
-            <a:spAutoFit/>
-          </a:bodyPr>
-          <a:lstStyle/>
-          <a:p>
-            <a:pPr algn="r"/>
-            <a:r>
-              <a:rPr sz="1000" b="1">
-                <a:solidFill>
-                  <a:srgbClr val="363C40"/>
-                </a:solidFill>
-                <a:latin typeface="Arial"/>
-              </a:rPr>
-              <a:t>86%</a:t>
-            </a:r>
-          </a:p>
-        </p:txBody>
-      </p:sp>
-      <p:sp>
-        <p:nvSpPr>
-          <p:cNvPr id="37" name="TextBox 36"/>
-          <p:cNvSpPr txBox="1"/>
-          <p:nvPr/>
-        </p:nvSpPr>
-        <p:spPr>
-          <a:xfrm>
-            <a:off x="3154680" y="3822191"/>
-            <a:ext cx="1234440" cy="237744"/>
-          </a:xfrm>
-          <a:prstGeom prst="rect">
-            <a:avLst/>
-          </a:prstGeom>
-          <a:noFill/>
-        </p:spPr>
-        <p:txBody>
-          <a:bodyPr wrap="square" lIns="0" rIns="0" tIns="0" bIns="0" anchor="t">
-            <a:spAutoFit/>
-          </a:bodyPr>
-          <a:lstStyle/>
-          <a:p>
-            <a:pPr algn="r"/>
-            <a:r>
-              <a:rPr sz="1000" b="0">
-                <a:solidFill>
-                  <a:srgbClr val="363C40"/>
-                </a:solidFill>
-                <a:latin typeface="Arial"/>
-              </a:rPr>
-              <a:t>1,007</a:t>
-            </a:r>
-          </a:p>
-        </p:txBody>
-      </p:sp>
-      <p:sp>
-        <p:nvSpPr>
-          <p:cNvPr id="38" name="Rounded Rectangle 37"/>
-          <p:cNvSpPr/>
-          <p:nvPr/>
-        </p:nvSpPr>
-        <p:spPr>
-          <a:xfrm>
-            <a:off x="329184" y="4128515"/>
-            <a:ext cx="4114800" cy="310896"/>
-          </a:xfrm>
-          <a:prstGeom prst="roundRect">
-            <a:avLst>
-              <a:gd name="adj" fmla="val 8000"/>
-            </a:avLst>
-          </a:prstGeom>
-          <a:solidFill>
-            <a:srgbClr val="F6F8F9"/>
-          </a:solidFill>
-          <a:ln>
-            <a:noFill/>
-          </a:ln>
-          <a:effectLst/>
-        </p:spPr>
-        <p:style>
-          <a:lnRef idx="1">
-            <a:schemeClr val="accent1"/>
-          </a:lnRef>
-          <a:fillRef idx="3">
-            <a:schemeClr val="accent1"/>
-          </a:fillRef>
-          <a:effectRef idx="2">
-            <a:schemeClr val="accent1"/>
-          </a:effectRef>
-          <a:fontRef idx="minor">
-            <a:schemeClr val="lt1"/>
-          </a:fontRef>
-        </p:style>
-        <p:txBody>
-          <a:bodyPr rtlCol="0" anchor="ctr"/>
-          <a:lstStyle/>
-          <a:p/>
-        </p:txBody>
-      </p:sp>
-      <p:sp>
-        <p:nvSpPr>
-          <p:cNvPr id="39" name="TextBox 38"/>
-          <p:cNvSpPr txBox="1"/>
-          <p:nvPr/>
-        </p:nvSpPr>
-        <p:spPr>
-          <a:xfrm>
-            <a:off x="384048" y="4169663"/>
-            <a:ext cx="1874519" cy="237744"/>
-          </a:xfrm>
-          <a:prstGeom prst="rect">
-            <a:avLst/>
-          </a:prstGeom>
-          <a:noFill/>
-        </p:spPr>
-        <p:txBody>
-          <a:bodyPr wrap="square" lIns="0" rIns="0" tIns="0" bIns="0" anchor="t">
-            <a:spAutoFit/>
-          </a:bodyPr>
-          <a:lstStyle/>
-          <a:p>
-            <a:pPr algn="l"/>
-            <a:r>
-              <a:rPr sz="1000" b="0">
-                <a:solidFill>
-                  <a:srgbClr val="363C40"/>
-                </a:solidFill>
-                <a:latin typeface="Arial"/>
-              </a:rPr>
-              <a:t>Port Huron</a:t>
-            </a:r>
-          </a:p>
-        </p:txBody>
-      </p:sp>
-      <p:sp>
-        <p:nvSpPr>
-          <p:cNvPr id="40" name="TextBox 39"/>
-          <p:cNvSpPr txBox="1"/>
-          <p:nvPr/>
-        </p:nvSpPr>
-        <p:spPr>
-          <a:xfrm>
-            <a:off x="2331720" y="4169663"/>
-            <a:ext cx="731520" cy="237744"/>
-          </a:xfrm>
-          <a:prstGeom prst="rect">
-            <a:avLst/>
-          </a:prstGeom>
-          <a:noFill/>
-        </p:spPr>
-        <p:txBody>
-          <a:bodyPr wrap="square" lIns="0" rIns="0" tIns="0" bIns="0" anchor="t">
-            <a:spAutoFit/>
-          </a:bodyPr>
-          <a:lstStyle/>
-          <a:p>
-            <a:pPr algn="r"/>
-            <a:r>
-              <a:rPr sz="1000" b="1">
-                <a:solidFill>
-                  <a:srgbClr val="CE4A57"/>
-                </a:solidFill>
-                <a:latin typeface="Arial"/>
-              </a:rPr>
-              <a:t>74%</a:t>
-            </a:r>
-          </a:p>
-        </p:txBody>
-      </p:sp>
-      <p:sp>
-        <p:nvSpPr>
-          <p:cNvPr id="41" name="TextBox 40"/>
-          <p:cNvSpPr txBox="1"/>
-          <p:nvPr/>
-        </p:nvSpPr>
-        <p:spPr>
-          <a:xfrm>
-            <a:off x="3154680" y="4169663"/>
-            <a:ext cx="1234440" cy="237744"/>
-          </a:xfrm>
-          <a:prstGeom prst="rect">
-            <a:avLst/>
-          </a:prstGeom>
-          <a:noFill/>
-        </p:spPr>
-        <p:txBody>
-          <a:bodyPr wrap="square" lIns="0" rIns="0" tIns="0" bIns="0" anchor="t">
-            <a:spAutoFit/>
-          </a:bodyPr>
-          <a:lstStyle/>
-          <a:p>
-            <a:pPr algn="r"/>
-            <a:r>
-              <a:rPr sz="1000" b="0">
-                <a:solidFill>
-                  <a:srgbClr val="363C40"/>
-                </a:solidFill>
-                <a:latin typeface="Arial"/>
-              </a:rPr>
-              <a:t>338</a:t>
-            </a:r>
-          </a:p>
-        </p:txBody>
-      </p:sp>
-      <p:sp>
-        <p:nvSpPr>
-          <p:cNvPr id="42" name="TextBox 41"/>
-          <p:cNvSpPr txBox="1"/>
-          <p:nvPr/>
-        </p:nvSpPr>
-        <p:spPr>
-          <a:xfrm>
-            <a:off x="384048" y="4517136"/>
-            <a:ext cx="1874519" cy="237744"/>
-          </a:xfrm>
-          <a:prstGeom prst="rect">
-            <a:avLst/>
-          </a:prstGeom>
-          <a:noFill/>
-        </p:spPr>
-        <p:txBody>
-          <a:bodyPr wrap="square" lIns="0" rIns="0" tIns="0" bIns="0" anchor="t">
-            <a:spAutoFit/>
-          </a:bodyPr>
-          <a:lstStyle/>
-          <a:p>
-            <a:pPr algn="l"/>
-            <a:r>
-              <a:rPr sz="1000" b="0">
-                <a:solidFill>
-                  <a:srgbClr val="363C40"/>
-                </a:solidFill>
-                <a:latin typeface="Arial"/>
-              </a:rPr>
-              <a:t>Southfield</a:t>
-            </a:r>
-          </a:p>
-        </p:txBody>
-      </p:sp>
-      <p:sp>
-        <p:nvSpPr>
-          <p:cNvPr id="43" name="TextBox 42"/>
-          <p:cNvSpPr txBox="1"/>
-          <p:nvPr/>
-        </p:nvSpPr>
-        <p:spPr>
-          <a:xfrm>
-            <a:off x="2331720" y="4517136"/>
-            <a:ext cx="731520" cy="237744"/>
-          </a:xfrm>
-          <a:prstGeom prst="rect">
-            <a:avLst/>
-          </a:prstGeom>
-          <a:noFill/>
-        </p:spPr>
-        <p:txBody>
-          <a:bodyPr wrap="square" lIns="0" rIns="0" tIns="0" bIns="0" anchor="t">
-            <a:spAutoFit/>
-          </a:bodyPr>
-          <a:lstStyle/>
-          <a:p>
-            <a:pPr algn="r"/>
-            <a:r>
-              <a:rPr sz="1000" b="1">
-                <a:solidFill>
-                  <a:srgbClr val="CE4A57"/>
-                </a:solidFill>
-                <a:latin typeface="Arial"/>
-              </a:rPr>
-              <a:t>61%</a:t>
-            </a:r>
-          </a:p>
-        </p:txBody>
-      </p:sp>
-      <p:sp>
-        <p:nvSpPr>
-          <p:cNvPr id="44" name="TextBox 43"/>
-          <p:cNvSpPr txBox="1"/>
-          <p:nvPr/>
-        </p:nvSpPr>
-        <p:spPr>
-          <a:xfrm>
-            <a:off x="3154680" y="4517136"/>
-            <a:ext cx="1234440" cy="237744"/>
-          </a:xfrm>
-          <a:prstGeom prst="rect">
-            <a:avLst/>
-          </a:prstGeom>
-          <a:noFill/>
-        </p:spPr>
-        <p:txBody>
-          <a:bodyPr wrap="square" lIns="0" rIns="0" tIns="0" bIns="0" anchor="t">
-            <a:spAutoFit/>
-          </a:bodyPr>
-          <a:lstStyle/>
-          <a:p>
-            <a:pPr algn="r"/>
-            <a:r>
-              <a:rPr sz="1000" b="0">
-                <a:solidFill>
-                  <a:srgbClr val="363C40"/>
-                </a:solidFill>
-                <a:latin typeface="Arial"/>
-              </a:rPr>
-              <a:t>175</a:t>
-            </a:r>
-          </a:p>
-        </p:txBody>
-      </p:sp>
-      <p:sp>
-        <p:nvSpPr>
-          <p:cNvPr id="45" name="Rounded Rectangle 44"/>
-          <p:cNvSpPr/>
-          <p:nvPr/>
-        </p:nvSpPr>
-        <p:spPr>
-          <a:xfrm>
-            <a:off x="329184" y="4823459"/>
-            <a:ext cx="4114800" cy="310896"/>
-          </a:xfrm>
-          <a:prstGeom prst="roundRect">
-            <a:avLst>
-              <a:gd name="adj" fmla="val 8000"/>
-            </a:avLst>
-          </a:prstGeom>
-          <a:solidFill>
-            <a:srgbClr val="F6F8F9"/>
-          </a:solidFill>
-          <a:ln>
-            <a:noFill/>
-          </a:ln>
-          <a:effectLst/>
-        </p:spPr>
-        <p:style>
-          <a:lnRef idx="1">
-            <a:schemeClr val="accent1"/>
-          </a:lnRef>
-          <a:fillRef idx="3">
-            <a:schemeClr val="accent1"/>
-          </a:fillRef>
-          <a:effectRef idx="2">
-            <a:schemeClr val="accent1"/>
-          </a:effectRef>
-          <a:fontRef idx="minor">
-            <a:schemeClr val="lt1"/>
-          </a:fontRef>
-        </p:style>
-        <p:txBody>
-          <a:bodyPr rtlCol="0" anchor="ctr"/>
-          <a:lstStyle/>
-          <a:p/>
-        </p:txBody>
-      </p:sp>
-      <p:sp>
-        <p:nvSpPr>
-          <p:cNvPr id="46" name="TextBox 45"/>
-          <p:cNvSpPr txBox="1"/>
-          <p:nvPr/>
-        </p:nvSpPr>
-        <p:spPr>
-          <a:xfrm>
-            <a:off x="384048" y="4864607"/>
-            <a:ext cx="1874519" cy="237744"/>
-          </a:xfrm>
-          <a:prstGeom prst="rect">
-            <a:avLst/>
-          </a:prstGeom>
-          <a:noFill/>
-        </p:spPr>
-        <p:txBody>
-          <a:bodyPr wrap="square" lIns="0" rIns="0" tIns="0" bIns="0" anchor="t">
-            <a:spAutoFit/>
-          </a:bodyPr>
-          <a:lstStyle/>
-          <a:p>
-            <a:pPr algn="l"/>
-            <a:r>
-              <a:rPr sz="1000" b="0">
-                <a:solidFill>
-                  <a:srgbClr val="363C40"/>
-                </a:solidFill>
-                <a:latin typeface="Arial"/>
-              </a:rPr>
-              <a:t>Troy</a:t>
-            </a:r>
-          </a:p>
-        </p:txBody>
-      </p:sp>
-      <p:sp>
-        <p:nvSpPr>
-          <p:cNvPr id="47" name="TextBox 46"/>
-          <p:cNvSpPr txBox="1"/>
-          <p:nvPr/>
-        </p:nvSpPr>
-        <p:spPr>
-          <a:xfrm>
-            <a:off x="2331720" y="4864607"/>
-            <a:ext cx="731520" cy="237744"/>
-          </a:xfrm>
-          <a:prstGeom prst="rect">
-            <a:avLst/>
-          </a:prstGeom>
-          <a:noFill/>
-        </p:spPr>
-        <p:txBody>
-          <a:bodyPr wrap="square" lIns="0" rIns="0" tIns="0" bIns="0" anchor="t">
-            <a:spAutoFit/>
-          </a:bodyPr>
-          <a:lstStyle/>
-          <a:p>
-            <a:pPr algn="r"/>
-            <a:r>
-              <a:rPr sz="1000" b="1">
-                <a:solidFill>
-                  <a:srgbClr val="CE4A57"/>
-                </a:solidFill>
-                <a:latin typeface="Arial"/>
-              </a:rPr>
-              <a:t>63%</a:t>
-            </a:r>
-          </a:p>
-        </p:txBody>
-      </p:sp>
-      <p:sp>
-        <p:nvSpPr>
-          <p:cNvPr id="48" name="TextBox 47"/>
-          <p:cNvSpPr txBox="1"/>
-          <p:nvPr/>
-        </p:nvSpPr>
-        <p:spPr>
-          <a:xfrm>
-            <a:off x="3154680" y="4864607"/>
-            <a:ext cx="1234440" cy="237744"/>
-          </a:xfrm>
-          <a:prstGeom prst="rect">
-            <a:avLst/>
-          </a:prstGeom>
-          <a:noFill/>
-        </p:spPr>
-        <p:txBody>
-          <a:bodyPr wrap="square" lIns="0" rIns="0" tIns="0" bIns="0" anchor="t">
-            <a:spAutoFit/>
-          </a:bodyPr>
-          <a:lstStyle/>
-          <a:p>
-            <a:pPr algn="r"/>
-            <a:r>
-              <a:rPr sz="1000" b="0">
-                <a:solidFill>
-                  <a:srgbClr val="363C40"/>
-                </a:solidFill>
-                <a:latin typeface="Arial"/>
-              </a:rPr>
-              <a:t>92</a:t>
-            </a:r>
-          </a:p>
-        </p:txBody>
-      </p:sp>
-      <p:sp>
-        <p:nvSpPr>
-          <p:cNvPr id="49" name="Rounded Rectangle 48"/>
-          <p:cNvSpPr/>
-          <p:nvPr/>
-        </p:nvSpPr>
-        <p:spPr>
-          <a:xfrm>
-            <a:off x="329184" y="5285232"/>
-            <a:ext cx="4114800" cy="786384"/>
-          </a:xfrm>
-          <a:prstGeom prst="roundRect">
-            <a:avLst>
-              <a:gd name="adj" fmla="val 8000"/>
-            </a:avLst>
-          </a:prstGeom>
-          <a:solidFill>
-            <a:srgbClr val="FFF7E0"/>
-          </a:solidFill>
-          <a:ln>
-            <a:noFill/>
-          </a:ln>
-          <a:effectLst/>
-        </p:spPr>
-        <p:style>
-          <a:lnRef idx="1">
-            <a:schemeClr val="accent1"/>
-          </a:lnRef>
-          <a:fillRef idx="3">
-            <a:schemeClr val="accent1"/>
-          </a:fillRef>
-          <a:effectRef idx="2">
-            <a:schemeClr val="accent1"/>
-          </a:effectRef>
-          <a:fontRef idx="minor">
-            <a:schemeClr val="lt1"/>
-          </a:fontRef>
-        </p:style>
-        <p:txBody>
-          <a:bodyPr rtlCol="0" anchor="ctr"/>
-          <a:lstStyle/>
-          <a:p/>
-        </p:txBody>
-      </p:sp>
-      <p:sp>
-        <p:nvSpPr>
-          <p:cNvPr id="50" name="TextBox 49"/>
-          <p:cNvSpPr txBox="1"/>
-          <p:nvPr/>
-        </p:nvSpPr>
-        <p:spPr>
-          <a:xfrm>
-            <a:off x="512064" y="5413248"/>
-            <a:ext cx="3803904" cy="566928"/>
-          </a:xfrm>
-          <a:prstGeom prst="rect">
-            <a:avLst/>
-          </a:prstGeom>
-          <a:noFill/>
-        </p:spPr>
-        <p:txBody>
-          <a:bodyPr wrap="square" lIns="0" rIns="0" tIns="0" bIns="0" anchor="t">
-            <a:spAutoFit/>
-          </a:bodyPr>
-          <a:lstStyle/>
-          <a:p>
-            <a:pPr algn="l"/>
-            <a:r>
-              <a:rPr sz="950" b="1">
-                <a:solidFill>
-                  <a:srgbClr val="363C40"/>
-                </a:solidFill>
-                <a:latin typeface="Arial"/>
-              </a:rPr>
-              <a:t>Fridays fill better than any other day (83%) — </a:t>
-            </a:r>
-          </a:p>
           <a:p>
             <a:pPr algn="l"/>
             <a:r>
@@ -14141,21 +13611,33 @@
                 </a:solidFill>
                 <a:latin typeface="Arial"/>
               </a:rPr>
-              <a:t>but we offer only 100 appointment times on a Friday versus 218 on a Thursday.</a:t>
-            </a:r>
-          </a:p>
-        </p:txBody>
-      </p:sp>
-      <p:sp>
-        <p:nvSpPr>
-          <p:cNvPr id="51" name="TextBox 50"/>
+              <a:t>Combined August and September</a:t>
+            </a:r>
+          </a:p>
+          <a:p>
+            <a:pPr algn="l"/>
+            <a:r>
+              <a:rPr sz="950" b="0">
+                <a:solidFill>
+                  <a:srgbClr val="363C40"/>
+                </a:solidFill>
+                <a:latin typeface="Arial"/>
+              </a:rPr>
+              <a:t>plan, to complete Q3</a:t>
+            </a:r>
+          </a:p>
+        </p:txBody>
+      </p:sp>
+      <p:sp>
+        <p:nvSpPr>
+          <p:cNvPr id="30" name="TextBox 29"/>
           <p:cNvSpPr txBox="1"/>
           <p:nvPr/>
         </p:nvSpPr>
         <p:spPr>
           <a:xfrm>
-            <a:off x="4736592" y="2944368"/>
-            <a:ext cx="4023360" cy="237744"/>
+            <a:off x="384048" y="2980944"/>
+            <a:ext cx="8375904" cy="237744"/>
           </a:xfrm>
           <a:prstGeom prst="rect">
             <a:avLst/>
@@ -14163,7 +13645,7 @@
           <a:noFill/>
         </p:spPr>
         <p:txBody>
-          <a:bodyPr wrap="square" lIns="0" rIns="0" tIns="0" bIns="0" anchor="t">
+          <a:bodyPr wrap="square" lIns="0" rIns="0" tIns="0" bIns="0">
             <a:spAutoFit/>
           </a:bodyPr>
           <a:lstStyle/>
@@ -14176,74 +13658,39 @@
                 </a:solidFill>
                 <a:latin typeface="Arial"/>
               </a:rPr>
-              <a:t>What would help most</a:t>
-            </a:r>
-          </a:p>
-        </p:txBody>
-      </p:sp>
-      <p:sp>
-        <p:nvSpPr>
-          <p:cNvPr id="52" name="Oval 51"/>
-          <p:cNvSpPr/>
+              <a:t>Average new Ortho patients per month, actual vs. plan</a:t>
+            </a:r>
+          </a:p>
+        </p:txBody>
+      </p:sp>
+      <p:graphicFrame>
+        <p:nvGraphicFramePr>
+          <p:cNvPr id="31" name="Chart 30"/>
+          <p:cNvGraphicFramePr>
+            <a:graphicFrameLocks noGrp="1"/>
+          </p:cNvGraphicFramePr>
           <p:nvPr/>
-        </p:nvSpPr>
-        <p:spPr>
-          <a:xfrm>
-            <a:off x="4736592" y="3273552"/>
-            <a:ext cx="274320" cy="274320"/>
-          </a:xfrm>
-          <a:prstGeom prst="ellipse">
-            <a:avLst/>
-          </a:prstGeom>
-          <a:solidFill>
-            <a:srgbClr val="49A698"/>
-          </a:solidFill>
-          <a:ln>
-            <a:noFill/>
-          </a:ln>
-          <a:effectLst/>
-        </p:spPr>
-        <p:style>
-          <a:lnRef idx="1">
-            <a:schemeClr val="accent1"/>
-          </a:lnRef>
-          <a:fillRef idx="3">
-            <a:schemeClr val="accent1"/>
-          </a:fillRef>
-          <a:effectRef idx="2">
-            <a:schemeClr val="accent1"/>
-          </a:effectRef>
-          <a:fontRef idx="minor">
-            <a:schemeClr val="lt1"/>
-          </a:fontRef>
-        </p:style>
-        <p:txBody>
-          <a:bodyPr rtlCol="0" anchor="ctr" lIns="0" rIns="0" tIns="0" bIns="0"/>
-          <a:lstStyle/>
-          <a:p>
-            <a:pPr algn="ctr"/>
-            <a:r>
-              <a:rPr sz="1100" b="1">
-                <a:solidFill>
-                  <a:srgbClr val="FFFFFF"/>
-                </a:solidFill>
-                <a:latin typeface="Arial"/>
-              </a:rPr>
-              <a:t>1</a:t>
-            </a:r>
-          </a:p>
-        </p:txBody>
-      </p:sp>
-      <p:sp>
-        <p:nvSpPr>
-          <p:cNvPr id="53" name="TextBox 52"/>
+        </p:nvGraphicFramePr>
+        <p:xfrm>
+          <a:off x="274320" y="3236976"/>
+          <a:ext cx="8595360" cy="2395728"/>
+        </p:xfrm>
+        <a:graphic>
+          <a:graphicData uri="http://schemas.openxmlformats.org/drawingml/2006/chart">
+            <c:chart xmlns:c="http://schemas.openxmlformats.org/drawingml/2006/chart" r:id="rId5"/>
+          </a:graphicData>
+        </a:graphic>
+      </p:graphicFrame>
+      <p:sp>
+        <p:nvSpPr>
+          <p:cNvPr id="32" name="TextBox 31"/>
           <p:cNvSpPr txBox="1"/>
           <p:nvPr/>
         </p:nvSpPr>
         <p:spPr>
           <a:xfrm>
-            <a:off x="5138928" y="3255264"/>
-            <a:ext cx="3621024" cy="219456"/>
+            <a:off x="384048" y="5724144"/>
+            <a:ext cx="8375904" cy="530352"/>
           </a:xfrm>
           <a:prstGeom prst="rect">
             <a:avLst/>
@@ -14251,34 +13698,34 @@
           <a:noFill/>
         </p:spPr>
         <p:txBody>
-          <a:bodyPr wrap="square" lIns="0" rIns="0" tIns="0" bIns="0" anchor="t">
+          <a:bodyPr wrap="square" lIns="0" rIns="0" tIns="0" bIns="0">
             <a:spAutoFit/>
           </a:bodyPr>
           <a:lstStyle/>
           <a:p>
             <a:pPr algn="l"/>
             <a:r>
-              <a:rPr sz="1050" b="1">
+              <a:rPr sz="1050" b="0">
                 <a:solidFill>
                   <a:srgbClr val="363C40"/>
                 </a:solidFill>
                 <a:latin typeface="Arial"/>
               </a:rPr>
-              <a:t>Add Friday clinic where you can.</a:t>
-            </a:r>
-          </a:p>
-        </p:txBody>
-      </p:sp>
-      <p:sp>
-        <p:nvSpPr>
-          <p:cNvPr id="54" name="TextBox 53"/>
+              <a:t>July delivered 534 patients against a plan of 523 — the highest plan attainment of any month this year. The full Q3 plan is 1,573 patients; the combined August and September plan is 1,050.</a:t>
+            </a:r>
+          </a:p>
+        </p:txBody>
+      </p:sp>
+      <p:sp>
+        <p:nvSpPr>
+          <p:cNvPr id="33" name="TextBox 32"/>
           <p:cNvSpPr txBox="1"/>
           <p:nvPr/>
         </p:nvSpPr>
         <p:spPr>
           <a:xfrm>
-            <a:off x="5138928" y="3493008"/>
-            <a:ext cx="3621024" cy="512064"/>
+            <a:off x="384048" y="6309360"/>
+            <a:ext cx="8375904" cy="182880"/>
           </a:xfrm>
           <a:prstGeom prst="rect">
             <a:avLst/>
@@ -14286,323 +13733,7 @@
           <a:noFill/>
         </p:spPr>
         <p:txBody>
-          <a:bodyPr wrap="square" lIns="0" rIns="0" tIns="0" bIns="0" anchor="t">
-            <a:spAutoFit/>
-          </a:bodyPr>
-          <a:lstStyle/>
-          <a:p>
-            <a:pPr algn="l"/>
-            <a:r>
-              <a:rPr sz="950" b="0">
-                <a:solidFill>
-                  <a:srgbClr val="6B7276"/>
-                </a:solidFill>
-                <a:latin typeface="Arial"/>
-              </a:rPr>
-              <a:t>Fridays are our best-filling day and our smallest. Matching Thursday is worth about 600 new patients a year.</a:t>
-            </a:r>
-          </a:p>
-        </p:txBody>
-      </p:sp>
-      <p:sp>
-        <p:nvSpPr>
-          <p:cNvPr id="55" name="Oval 54"/>
-          <p:cNvSpPr/>
-          <p:nvPr/>
-        </p:nvSpPr>
-        <p:spPr>
-          <a:xfrm>
-            <a:off x="4736592" y="4133087"/>
-            <a:ext cx="274320" cy="274320"/>
-          </a:xfrm>
-          <a:prstGeom prst="ellipse">
-            <a:avLst/>
-          </a:prstGeom>
-          <a:solidFill>
-            <a:srgbClr val="49A698"/>
-          </a:solidFill>
-          <a:ln>
-            <a:noFill/>
-          </a:ln>
-          <a:effectLst/>
-        </p:spPr>
-        <p:style>
-          <a:lnRef idx="1">
-            <a:schemeClr val="accent1"/>
-          </a:lnRef>
-          <a:fillRef idx="3">
-            <a:schemeClr val="accent1"/>
-          </a:fillRef>
-          <a:effectRef idx="2">
-            <a:schemeClr val="accent1"/>
-          </a:effectRef>
-          <a:fontRef idx="minor">
-            <a:schemeClr val="lt1"/>
-          </a:fontRef>
-        </p:style>
-        <p:txBody>
-          <a:bodyPr rtlCol="0" anchor="ctr" lIns="0" rIns="0" tIns="0" bIns="0"/>
-          <a:lstStyle/>
-          <a:p>
-            <a:pPr algn="ctr"/>
-            <a:r>
-              <a:rPr sz="1100" b="1">
-                <a:solidFill>
-                  <a:srgbClr val="FFFFFF"/>
-                </a:solidFill>
-                <a:latin typeface="Arial"/>
-              </a:rPr>
-              <a:t>2</a:t>
-            </a:r>
-          </a:p>
-        </p:txBody>
-      </p:sp>
-      <p:sp>
-        <p:nvSpPr>
-          <p:cNvPr id="56" name="TextBox 55"/>
-          <p:cNvSpPr txBox="1"/>
-          <p:nvPr/>
-        </p:nvSpPr>
-        <p:spPr>
-          <a:xfrm>
-            <a:off x="5138928" y="4114800"/>
-            <a:ext cx="3621024" cy="219456"/>
-          </a:xfrm>
-          <a:prstGeom prst="rect">
-            <a:avLst/>
-          </a:prstGeom>
-          <a:noFill/>
-        </p:spPr>
-        <p:txBody>
-          <a:bodyPr wrap="square" lIns="0" rIns="0" tIns="0" bIns="0" anchor="t">
-            <a:spAutoFit/>
-          </a:bodyPr>
-          <a:lstStyle/>
-          <a:p>
-            <a:pPr algn="l"/>
-            <a:r>
-              <a:rPr sz="1050" b="1">
-                <a:solidFill>
-                  <a:srgbClr val="363C40"/>
-                </a:solidFill>
-                <a:latin typeface="Arial"/>
-              </a:rPr>
-              <a:t>Open more Sterling Heights time.</a:t>
-            </a:r>
-          </a:p>
-        </p:txBody>
-      </p:sp>
-      <p:sp>
-        <p:nvSpPr>
-          <p:cNvPr id="57" name="TextBox 56"/>
-          <p:cNvSpPr txBox="1"/>
-          <p:nvPr/>
-        </p:nvSpPr>
-        <p:spPr>
-          <a:xfrm>
-            <a:off x="5138928" y="4352544"/>
-            <a:ext cx="3621024" cy="512064"/>
-          </a:xfrm>
-          <a:prstGeom prst="rect">
-            <a:avLst/>
-          </a:prstGeom>
-          <a:noFill/>
-        </p:spPr>
-        <p:txBody>
-          <a:bodyPr wrap="square" lIns="0" rIns="0" tIns="0" bIns="0" anchor="t">
-            <a:spAutoFit/>
-          </a:bodyPr>
-          <a:lstStyle/>
-          <a:p>
-            <a:pPr algn="l"/>
-            <a:r>
-              <a:rPr sz="950" b="0">
-                <a:solidFill>
-                  <a:srgbClr val="6B7276"/>
-                </a:solidFill>
-                <a:latin typeface="Arial"/>
-              </a:rPr>
-              <a:t>It holds 1,621 of our 3,233 unused appointments — the single largest pocket of open capacity.</a:t>
-            </a:r>
-          </a:p>
-        </p:txBody>
-      </p:sp>
-      <p:sp>
-        <p:nvSpPr>
-          <p:cNvPr id="58" name="Oval 57"/>
-          <p:cNvSpPr/>
-          <p:nvPr/>
-        </p:nvSpPr>
-        <p:spPr>
-          <a:xfrm>
-            <a:off x="4736592" y="4992623"/>
-            <a:ext cx="274320" cy="274320"/>
-          </a:xfrm>
-          <a:prstGeom prst="ellipse">
-            <a:avLst/>
-          </a:prstGeom>
-          <a:solidFill>
-            <a:srgbClr val="49A698"/>
-          </a:solidFill>
-          <a:ln>
-            <a:noFill/>
-          </a:ln>
-          <a:effectLst/>
-        </p:spPr>
-        <p:style>
-          <a:lnRef idx="1">
-            <a:schemeClr val="accent1"/>
-          </a:lnRef>
-          <a:fillRef idx="3">
-            <a:schemeClr val="accent1"/>
-          </a:fillRef>
-          <a:effectRef idx="2">
-            <a:schemeClr val="accent1"/>
-          </a:effectRef>
-          <a:fontRef idx="minor">
-            <a:schemeClr val="lt1"/>
-          </a:fontRef>
-        </p:style>
-        <p:txBody>
-          <a:bodyPr rtlCol="0" anchor="ctr" lIns="0" rIns="0" tIns="0" bIns="0"/>
-          <a:lstStyle/>
-          <a:p>
-            <a:pPr algn="ctr"/>
-            <a:r>
-              <a:rPr sz="1100" b="1">
-                <a:solidFill>
-                  <a:srgbClr val="FFFFFF"/>
-                </a:solidFill>
-                <a:latin typeface="Arial"/>
-              </a:rPr>
-              <a:t>3</a:t>
-            </a:r>
-          </a:p>
-        </p:txBody>
-      </p:sp>
-      <p:sp>
-        <p:nvSpPr>
-          <p:cNvPr id="59" name="TextBox 58"/>
-          <p:cNvSpPr txBox="1"/>
-          <p:nvPr/>
-        </p:nvSpPr>
-        <p:spPr>
-          <a:xfrm>
-            <a:off x="5138928" y="4974336"/>
-            <a:ext cx="3621024" cy="219456"/>
-          </a:xfrm>
-          <a:prstGeom prst="rect">
-            <a:avLst/>
-          </a:prstGeom>
-          <a:noFill/>
-        </p:spPr>
-        <p:txBody>
-          <a:bodyPr wrap="square" lIns="0" rIns="0" tIns="0" bIns="0" anchor="t">
-            <a:spAutoFit/>
-          </a:bodyPr>
-          <a:lstStyle/>
-          <a:p>
-            <a:pPr algn="l"/>
-            <a:r>
-              <a:rPr sz="1050" b="1">
-                <a:solidFill>
-                  <a:srgbClr val="363C40"/>
-                </a:solidFill>
-                <a:latin typeface="Arial"/>
-              </a:rPr>
-              <a:t>Tell us where you have room.</a:t>
-            </a:r>
-          </a:p>
-        </p:txBody>
-      </p:sp>
-      <p:sp>
-        <p:nvSpPr>
-          <p:cNvPr id="60" name="TextBox 59"/>
-          <p:cNvSpPr txBox="1"/>
-          <p:nvPr/>
-        </p:nvSpPr>
-        <p:spPr>
-          <a:xfrm>
-            <a:off x="5138928" y="5212079"/>
-            <a:ext cx="3621024" cy="512064"/>
-          </a:xfrm>
-          <a:prstGeom prst="rect">
-            <a:avLst/>
-          </a:prstGeom>
-          <a:noFill/>
-        </p:spPr>
-        <p:txBody>
-          <a:bodyPr wrap="square" lIns="0" rIns="0" tIns="0" bIns="0" anchor="t">
-            <a:spAutoFit/>
-          </a:bodyPr>
-          <a:lstStyle/>
-          <a:p>
-            <a:pPr algn="l"/>
-            <a:r>
-              <a:rPr sz="950" b="0">
-                <a:solidFill>
-                  <a:srgbClr val="6B7276"/>
-                </a:solidFill>
-                <a:latin typeface="Arial"/>
-              </a:rPr>
-              <a:t>We will point new-patient scheduling and advertising at the clinics with space, instead of the ones already full.</a:t>
-            </a:r>
-          </a:p>
-        </p:txBody>
-      </p:sp>
-      <p:sp>
-        <p:nvSpPr>
-          <p:cNvPr id="61" name="TextBox 60"/>
-          <p:cNvSpPr txBox="1"/>
-          <p:nvPr/>
-        </p:nvSpPr>
-        <p:spPr>
-          <a:xfrm>
-            <a:off x="4736592" y="5888736"/>
-            <a:ext cx="4023360" cy="219456"/>
-          </a:xfrm>
-          <a:prstGeom prst="rect">
-            <a:avLst/>
-          </a:prstGeom>
-          <a:noFill/>
-        </p:spPr>
-        <p:txBody>
-          <a:bodyPr wrap="square" lIns="0" rIns="0" tIns="0" bIns="0" anchor="t">
-            <a:spAutoFit/>
-          </a:bodyPr>
-          <a:lstStyle/>
-          <a:p>
-            <a:pPr algn="l"/>
-            <a:r>
-              <a:rPr sz="950" b="1">
-                <a:solidFill>
-                  <a:srgbClr val="49A698"/>
-                </a:solidFill>
-                <a:latin typeface="Arial"/>
-              </a:rPr>
-              <a:t>Marketing owns filling the schedule. We need to know where the room is.</a:t>
-            </a:r>
-          </a:p>
-        </p:txBody>
-      </p:sp>
-      <p:sp>
-        <p:nvSpPr>
-          <p:cNvPr id="62" name="TextBox 61"/>
-          <p:cNvSpPr txBox="1"/>
-          <p:nvPr/>
-        </p:nvSpPr>
-        <p:spPr>
-          <a:xfrm>
-            <a:off x="384048" y="6309360"/>
-            <a:ext cx="8375904" cy="182880"/>
-          </a:xfrm>
-          <a:prstGeom prst="rect">
-            <a:avLst/>
-          </a:prstGeom>
-          <a:noFill/>
-        </p:spPr>
-        <p:txBody>
-          <a:bodyPr wrap="square" lIns="0" rIns="0" tIns="0" bIns="0" anchor="t">
+          <a:bodyPr wrap="square" lIns="0" rIns="0" tIns="0" bIns="0">
             <a:spAutoFit/>
           </a:bodyPr>
           <a:lstStyle/>
@@ -14615,7 +13746,7 @@
                 </a:solidFill>
                 <a:latin typeface="Arial"/>
               </a:rPr>
-              <a:t>Source: Clinic Capacity Dashboard, Ortho service line, 30 March – 30 July 2026. "Open times" = scheduled appointment slots that went unbooked.</a:t>
+              <a:t>Source: EMR new-patient report, first appointment date, pulled 30 July 2026. July includes appointments booked through 31 July.</a:t>
             </a:r>
           </a:p>
         </p:txBody>

</xml_diff>